<commit_message>
Agregar link del repo en la slide de DEMO
Co-Authored-By: Claude Opus 4.8 <noreply@anthropic.com>
</commit_message>
<xml_diff>
--- a/CWE-787-Out-of-bounds-Write.pptx
+++ b/CWE-787-Out-of-bounds-Write.pptx
@@ -3671,14 +3671,14 @@
                 <a:ea typeface="Roboto Light"/>
                 <a:hlinkClick r:id="rId3"/>
               </a:rPr>
-              <a:t>localhost:8000</a:t>
+              <a:t>github.com/juanmato/cwe-787-out-of-bounds-write-demo</a:t>
             </a:r>
             <a:r>
               <a:rPr lang="es-UY">
                 <a:latin typeface="Myriad Pro"/>
                 <a:ea typeface="Roboto Light"/>
               </a:rPr>
-              <a:t>     ·     TechStore (carpeta demo-cwe787/)</a:t>
+              <a:t/>
             </a:r>
             <a:endParaRPr lang="es-UY" dirty="0"/>
           </a:p>

</xml_diff>